<commit_message>
Slides : chiffres officiels de Fabric, sans délinquance ; deck données aux couleurs de Citiz (#38)
</commit_message>
<xml_diff>
--- a/slides/citiz_soutenance.pptx
+++ b/slides/citiz_soutenance.pptx
@@ -167,7 +167,7 @@
                 </a:solidFill>
                 <a:latin typeface="+mn-lt"/>
               </a:rPr>
-              <a:t>Stations de Grenoble (168) dans les carreaux jugés les plus favorables</a:t>
+              <a:t>Stations de Grenoble (177) dans les carreaux jugés les plus favorables</a:t>
             </a:r>
           </a:p>
         </c:rich>
@@ -253,10 +253,10 @@
                 <c:formatCode>General</c:formatCode>
                 <c:ptCount val="3"/>
                 <c:pt idx="0">
-                  <c:v>55</c:v>
+                  <c:v>53</c:v>
                 </c:pt>
                 <c:pt idx="1">
-                  <c:v>69</c:v>
+                  <c:v>68</c:v>
                 </c:pt>
                 <c:pt idx="2">
                   <c:v>89</c:v>
@@ -336,13 +336,13 @@
                 <c:formatCode>General</c:formatCode>
                 <c:ptCount val="3"/>
                 <c:pt idx="0">
-                  <c:v>52</c:v>
+                  <c:v>53</c:v>
                 </c:pt>
                 <c:pt idx="1">
-                  <c:v>65</c:v>
+                  <c:v>64</c:v>
                 </c:pt>
                 <c:pt idx="2">
-                  <c:v>82</c:v>
+                  <c:v>80</c:v>
                 </c:pt>
               </c:numCache>
             </c:numRef>
@@ -985,7 +985,7 @@
           <a:p>
             <a:r>
               <a:rPr lang="en-US" dirty="0"/>
-              <a:t>(30 s) Le problème : en mesurant la vraie marche, sur les rues, seul un Nantais sur cinq a une voiture partagée à 5 minutes, Citiz et Marguerite confondus, alors que 80 % ont un bus, un tram ou un vélo. Et 93 000 habitants dépendent d'un seul arrêt. Le besoin de Citiz : avec un budget donné, où ouvrir ses prochaines stations pour toucher le plus d'habitants ?</a:t>
+              <a:t>(30 s) Le problème : en mesurant la vraie marche, sur les rues, seul un Nantais sur cinq a une voiture partagée à 5 minutes, Citiz et Marguerite confondus, alors que 80 % ont un bus, un tram ou un vélo. Et 107 000 habitants dépendent d'un seul arrêt. Le besoin de Citiz : avec un budget donné, où ouvrir ses prochaines stations pour toucher le plus d'habitants ?</a:t>
             </a:r>
             <a:endParaRPr lang="en-US" dirty="0"/>
           </a:p>
@@ -1076,7 +1076,7 @@
               <a:t>(40 s) Notre outil fait quatre choses. Il mesure l'accès à 5 minutes de vraie marche pour chaque carreau de 200 m. Il prédit où une station Citiz fonctionne : testé à l'aveugle sur Grenoble, il retrouve 89 % des stations. Il choisit les stations qui ajoutent le plus d'habitants pour le budget. Et il restitue tout dans Power BI. Toute la chaîne tourne dans Microsoft Fabric. Place à la démo.
 DÉMO (2 min 45), rapport Power BI citiz_acces_investissement :
 1. Page « Nantes : diagnostic » : la carte, 19 % à 5 min d'un autopartage.
-2. Page « Nantes : où investir » : budget 500 000 €, la carte des 12 stations et la liste priorisée ; passer à 1 000 000 €.
+2. Page « Nantes : où investir » : budget 500 000 €, la carte des 13 stations et la liste priorisée ; passer à 1 000 000 €.
 3. Page « Rentabilité d'une station » : saisir les valeurs, montrer le seuil de rentabilité.
 4. Si le temps le permet : un run réussi du pipeline dans l'onglet Surveiller de Fabric (pas de lancement en direct).
 Plan B : application Streamlit (lancer_demo.bat) ou captures de slides/img/demo/.</a:t>
@@ -1167,7 +1167,7 @@
           <a:p>
             <a:r>
               <a:rPr lang="en-US" dirty="0"/>
-              <a:t>(45 s) Notre recommandation : avec 500 000 €, 12 stations. 35 000 Nantais de plus se retrouvent à 5 minutes à pied d'une voiture partagée : la couverture passe de 19,0 % à 24,1 %, pour 13,6 € par habitant sur 3 ans, et 17 tonnes de CO2 évitées par an. Hypothèse de coût : 37 900 € par station sur 3 ans, à valider avec Citiz. Avec 1 M€, 25 stations et 59 000 habitants : chaque euro rapporte un peu moins, l'outil montre où s'arrêter. Limite principale : le modèle apprend où Citiz s'est installé, pas une demande mesurée. Merci, place aux questions.</a:t>
+              <a:t>(45 s) Notre recommandation : avec 500 000 €, 13 stations. 22 500 Nantais de plus se retrouvent à 5 minutes à pied d'une voiture partagée : la couverture passe de 19,0 % à 22,3 %, pour 21,9 € par habitant sur 3 ans, et 18 tonnes de CO2 évitées par an. Hypothèse de coût : 37 900 € par station sur 3 ans, à valider avec Citiz. Avec 1 M€, 26 stations et 50 000 habitants, pour un coût par habitant comparable (19,6 €) : l'outil aide à arbitrer le budget. Aucune donnée de délinquance n'entre dans le calcul. Limite principale : le modèle apprend où Citiz s'est installé, pas une demande mesurée. Merci, place aux questions.</a:t>
             </a:r>
             <a:endParaRPr lang="en-US" dirty="0"/>
           </a:p>
@@ -1255,7 +1255,7 @@
           <a:p>
             <a:r>
               <a:rPr lang="en-US" dirty="0"/>
-              <a:t>Peut-on faire confiance au modèle ? Il apprend, sur toute la France, à quoi ressemble un carreau qui a une station Citiz. Pour le tester, on lui a caché tout le réseau de Grenoble. Il retrouve 89 % des stations dans les 20 % de carreaux qu'il juge les plus favorables, contre 82 % avec la densité seule. Limite assumée : il apprend où Citiz s'est installé, pas une demande mesurée.</a:t>
+              <a:t>Peut-on faire confiance au modèle ? Il apprend, sur toute la France, à quoi ressemble un carreau qui a une station Citiz. Pour le tester, on lui a caché tout le réseau de Grenoble. Il retrouve 89 % des stations dans les 20 % de carreaux qu'il juge les plus favorables, contre 80 % avec la densité seule. Limite assumée : il apprend où Citiz s'est installé, pas une demande mesurée.</a:t>
             </a:r>
             <a:endParaRPr lang="en-US" dirty="0"/>
           </a:p>
@@ -1607,7 +1607,7 @@
           <a:p>
             <a:r>
               <a:rPr lang="en-US" dirty="0"/>
-              <a:t>Voici la France entière, carreau de 200 m par carreau de 200 m. Un habitant sur quatre (25,9 %) n'a aucune option de mobilité à 5 minutes à pied : ni bus, ni tram, ni vélo, ni voiture partagée. Et c'est une estimation optimiste, calculée à vol d'oiseau. Seuls 5,6 % des Français ont une station Citiz à 5 minutes.</a:t>
+              <a:t>Voici la France entière, carreau de 200 m par carreau de 200 m. Un habitant sur quatre (24,1 %) n'a aucune option de mobilité à 5 minutes à pied : ni bus, ni tram, ni vélo, ni voiture partagée. Et c'est une estimation optimiste, calculée à vol d'oiseau. Seuls 5,6 % des Français ont une station Citiz à 5 minutes.</a:t>
             </a:r>
             <a:endParaRPr lang="en-US" dirty="0"/>
           </a:p>
@@ -2796,7 +2796,7 @@
                   <a:schemeClr val="accent2"/>
                 </a:solidFill>
               </a:rPr>
-              <a:t>80,6 %</a:t>
+              <a:t>80,7 %</a:t>
             </a:r>
             <a:endParaRPr lang="en-US" sz="3400" dirty="0"/>
           </a:p>
@@ -2868,7 +2868,7 @@
                   <a:schemeClr val="accent3"/>
                 </a:solidFill>
               </a:rPr>
-              <a:t>92 883</a:t>
+              <a:t>107 205</a:t>
             </a:r>
             <a:endParaRPr lang="en-US" sz="3400" dirty="0"/>
           </a:p>
@@ -4224,7 +4224,7 @@
                   <a:schemeClr val="tx1"/>
                 </a:solidFill>
               </a:rPr>
-              <a:t>Avec 500 000 €, 12 stations rapprochent 35 000 Nantais d'une voiture partagée</a:t>
+              <a:t>Avec 500 000 €, 13 stations rapprochent 22 500 Nantais d'une voiture partagée</a:t>
             </a:r>
             <a:endParaRPr lang="en-US" sz="2400" dirty="0"/>
           </a:p>
@@ -4345,7 +4345,7 @@
                   <a:schemeClr val="accent2"/>
                 </a:solidFill>
               </a:rPr>
-              <a:t>12</a:t>
+              <a:t>13</a:t>
             </a:r>
             <a:endParaRPr lang="en-US" sz="2400" dirty="0"/>
           </a:p>
@@ -4444,7 +4444,7 @@
                   <a:schemeClr val="accent2"/>
                 </a:solidFill>
               </a:rPr>
-              <a:t>+34 979</a:t>
+              <a:t>+22 510</a:t>
             </a:r>
             <a:endParaRPr lang="en-US" sz="2400" dirty="0"/>
           </a:p>
@@ -4543,7 +4543,7 @@
                   <a:schemeClr val="accent2"/>
                 </a:solidFill>
               </a:rPr>
-              <a:t>24,1 %</a:t>
+              <a:t>22,3 %</a:t>
             </a:r>
             <a:endParaRPr lang="en-US" sz="2400" dirty="0"/>
           </a:p>
@@ -4642,7 +4642,7 @@
                   <a:schemeClr val="accent2"/>
                 </a:solidFill>
               </a:rPr>
-              <a:t>13,6 €</a:t>
+              <a:t>21,9 €</a:t>
             </a:r>
             <a:endParaRPr lang="en-US" sz="2400" dirty="0"/>
           </a:p>
@@ -4714,7 +4714,7 @@
                   <a:schemeClr val="tx1"/>
                 </a:solidFill>
               </a:rPr>
-              <a:t>Avec 1 M€ : 25 stations, +59 039 habitants</a:t>
+              <a:t>Avec 1 M€ : 26 stations, +50 290 habitants</a:t>
             </a:r>
             <a:endParaRPr lang="en-US" sz="1200" dirty="0"/>
           </a:p>
@@ -4976,7 +4976,7 @@
                   <a:schemeClr val="tx1"/>
                 </a:solidFill>
               </a:rPr>
-              <a:t>LightGBM, 313 000 carreaux</a:t>
+              <a:t>LightGBM, 2,3 M carreaux</a:t>
             </a:r>
             <a:endParaRPr lang="en-US" sz="1400" dirty="0"/>
           </a:p>
@@ -5075,7 +5075,7 @@
                   <a:schemeClr val="tx1"/>
                 </a:solidFill>
               </a:rPr>
-              <a:t>AUC 0,953 à Grenoble</a:t>
+              <a:t>AUC 0,935 à Grenoble</a:t>
             </a:r>
             <a:endParaRPr lang="en-US" sz="1400" dirty="0"/>
           </a:p>
@@ -5089,7 +5089,7 @@
                   <a:schemeClr val="tx2"/>
                 </a:solidFill>
               </a:rPr>
-              <a:t>0,922 sur les 15 réseaux, chacun prédit sans l'avoir vu</a:t>
+              <a:t>0,989 en médiane sur 12 régions, chacune prédite sans l'avoir vue</a:t>
             </a:r>
             <a:endParaRPr lang="en-US" sz="1400" dirty="0"/>
           </a:p>
@@ -5188,7 +5188,7 @@
                   <a:schemeClr val="tx2"/>
                 </a:solidFill>
               </a:rPr>
-              <a:t>équipements à 400 m, vols de véhicules, ménages sans voiture, densité</a:t>
+              <a:t>densité à 400 m et 1 km, transports, ménages sans voiture, niveau de vie</a:t>
             </a:r>
             <a:endParaRPr lang="en-US" sz="1400" dirty="0"/>
           </a:p>
@@ -8136,7 +8136,7 @@
                   <a:schemeClr val="accent4"/>
                 </a:solidFill>
               </a:rPr>
-              <a:t>25,9 %</a:t>
+              <a:t>24,1 %</a:t>
             </a:r>
             <a:endParaRPr lang="en-US" sz="6000" dirty="0"/>
           </a:p>

</xml_diff>